<commit_message>
Refine problem slides and update 5-minute presentation downloads
</commit_message>
<xml_diff>
--- a/5g-thesis-presentation-5min/tesi-5min.pptx
+++ b/5g-thesis-presentation-5min/tesi-5min.pptx
@@ -7314,7 +7314,7 @@
                 <a:ea typeface="Arial"/>
                 <a:cs typeface="Arial"/>
               </a:rPr>
-              <a:t>IL PROBLEMA</a:t>
+              <a:t>PROBLEMA</a:t>
             </a:r>
           </a:p>
         </p:txBody>
@@ -7812,7 +7812,7 @@
         </p:nvSpPr>
         <p:spPr>
           <a:xfrm xmlns:a="http://schemas.openxmlformats.org/drawingml/2006/main">
-            <a:off x="1066800" y="2647950"/>
+            <a:off x="1066800" y="3105150"/>
             <a:ext cx="4476750" cy="476250"/>
           </a:xfrm>
           <a:prstGeom xmlns:a="http://schemas.openxmlformats.org/drawingml/2006/main" prst="rect">
@@ -7971,7 +7971,7 @@
         </p:nvSpPr>
         <p:spPr>
           <a:xfrm xmlns:a="http://schemas.openxmlformats.org/drawingml/2006/main">
-            <a:off x="9696450" y="2647950"/>
+            <a:off x="9696450" y="3105150"/>
             <a:ext cx="4476750" cy="476250"/>
           </a:xfrm>
           <a:prstGeom xmlns:a="http://schemas.openxmlformats.org/drawingml/2006/main" prst="rect">
@@ -8130,7 +8130,7 @@
         </p:nvSpPr>
         <p:spPr>
           <a:xfrm xmlns:a="http://schemas.openxmlformats.org/drawingml/2006/main">
-            <a:off x="2171700" y="3467100"/>
+            <a:off x="2171700" y="3924300"/>
             <a:ext cx="2190750" cy="2000250"/>
           </a:xfrm>
           <a:prstGeom xmlns:a="http://schemas.openxmlformats.org/drawingml/2006/main" prst="roundRect">
@@ -8165,7 +8165,7 @@
         </p:nvSpPr>
         <p:spPr>
           <a:xfrm xmlns:a="http://schemas.openxmlformats.org/drawingml/2006/main">
-            <a:off x="2609850" y="4067175"/>
+            <a:off x="2609850" y="4524375"/>
             <a:ext cx="1270635" cy="95"/>
           </a:xfrm>
           <a:prstGeom xmlns:a="http://schemas.openxmlformats.org/drawingml/2006/main" prst="line">
@@ -8196,7 +8196,7 @@
         </p:nvSpPr>
         <p:spPr>
           <a:xfrm xmlns:a="http://schemas.openxmlformats.org/drawingml/2006/main">
-            <a:off x="2609850" y="4427220"/>
+            <a:off x="2609850" y="4884420"/>
             <a:ext cx="1270635" cy="95"/>
           </a:xfrm>
           <a:prstGeom xmlns:a="http://schemas.openxmlformats.org/drawingml/2006/main" prst="line">
@@ -8227,7 +8227,7 @@
         </p:nvSpPr>
         <p:spPr>
           <a:xfrm xmlns:a="http://schemas.openxmlformats.org/drawingml/2006/main">
-            <a:off x="2609850" y="4787265"/>
+            <a:off x="2609850" y="5244465"/>
             <a:ext cx="1270635" cy="95"/>
           </a:xfrm>
           <a:prstGeom xmlns:a="http://schemas.openxmlformats.org/drawingml/2006/main" prst="line">
@@ -8258,7 +8258,7 @@
         </p:nvSpPr>
         <p:spPr>
           <a:xfrm xmlns:a="http://schemas.openxmlformats.org/drawingml/2006/main">
-            <a:off x="10629900" y="3609975"/>
+            <a:off x="10629900" y="4067175"/>
             <a:ext cx="2667000" cy="1714500"/>
           </a:xfrm>
           <a:prstGeom xmlns:a="http://schemas.openxmlformats.org/drawingml/2006/main" prst="roundRect">
@@ -8293,7 +8293,7 @@
         </p:nvSpPr>
         <p:spPr>
           <a:xfrm xmlns:a="http://schemas.openxmlformats.org/drawingml/2006/main">
-            <a:off x="10629900" y="3971925"/>
+            <a:off x="10629900" y="4429125"/>
             <a:ext cx="2667000" cy="95"/>
           </a:xfrm>
           <a:prstGeom xmlns:a="http://schemas.openxmlformats.org/drawingml/2006/main" prst="line">
@@ -8324,7 +8324,7 @@
         </p:nvSpPr>
         <p:spPr>
           <a:xfrm xmlns:a="http://schemas.openxmlformats.org/drawingml/2006/main">
-            <a:off x="10801350" y="3752850"/>
+            <a:off x="10801350" y="4210050"/>
             <a:ext cx="76200" cy="76200"/>
           </a:xfrm>
           <a:prstGeom xmlns:a="http://schemas.openxmlformats.org/drawingml/2006/main" prst="ellipse">
@@ -8357,7 +8357,7 @@
         </p:nvSpPr>
         <p:spPr>
           <a:xfrm xmlns:a="http://schemas.openxmlformats.org/drawingml/2006/main">
-            <a:off x="10991850" y="3752850"/>
+            <a:off x="10991850" y="4210050"/>
             <a:ext cx="76200" cy="76200"/>
           </a:xfrm>
           <a:prstGeom xmlns:a="http://schemas.openxmlformats.org/drawingml/2006/main" prst="ellipse">
@@ -8390,7 +8390,7 @@
         </p:nvSpPr>
         <p:spPr>
           <a:xfrm xmlns:a="http://schemas.openxmlformats.org/drawingml/2006/main">
-            <a:off x="11182350" y="3752850"/>
+            <a:off x="11182350" y="4210050"/>
             <a:ext cx="76200" cy="76200"/>
           </a:xfrm>
           <a:prstGeom xmlns:a="http://schemas.openxmlformats.org/drawingml/2006/main" prst="ellipse">
@@ -8423,7 +8423,7 @@
         </p:nvSpPr>
         <p:spPr>
           <a:xfrm xmlns:a="http://schemas.openxmlformats.org/drawingml/2006/main">
-            <a:off x="10915650" y="4238625"/>
+            <a:off x="10915650" y="4695825"/>
             <a:ext cx="2095500" cy="647700"/>
           </a:xfrm>
           <a:prstGeom xmlns:a="http://schemas.openxmlformats.org/drawingml/2006/main" prst="rect">
@@ -8582,7 +8582,7 @@
         </p:nvSpPr>
         <p:spPr>
           <a:xfrm xmlns:a="http://schemas.openxmlformats.org/drawingml/2006/main">
-            <a:off x="4657725" y="4257675"/>
+            <a:off x="4657725" y="4714875"/>
             <a:ext cx="1133475" cy="219075"/>
           </a:xfrm>
           <a:prstGeom xmlns:a="http://schemas.openxmlformats.org/drawingml/2006/main" prst="rightArrow">
@@ -8613,7 +8613,7 @@
         </p:nvSpPr>
         <p:spPr>
           <a:xfrm xmlns:a="http://schemas.openxmlformats.org/drawingml/2006/main">
-            <a:off x="9448800" y="4257675"/>
+            <a:off x="9448800" y="4714875"/>
             <a:ext cx="942975" cy="219075"/>
           </a:xfrm>
           <a:prstGeom xmlns:a="http://schemas.openxmlformats.org/drawingml/2006/main" prst="leftArrow">
@@ -8644,7 +8644,7 @@
         </p:nvSpPr>
         <p:spPr>
           <a:xfrm xmlns:a="http://schemas.openxmlformats.org/drawingml/2006/main">
-            <a:off x="5943600" y="3638550"/>
+            <a:off x="5943600" y="4095750"/>
             <a:ext cx="3352800" cy="1390650"/>
           </a:xfrm>
           <a:prstGeom xmlns:a="http://schemas.openxmlformats.org/drawingml/2006/main" prst="roundRect">
@@ -8679,7 +8679,7 @@
         </p:nvSpPr>
         <p:spPr>
           <a:xfrm xmlns:a="http://schemas.openxmlformats.org/drawingml/2006/main">
-            <a:off x="6048375" y="3867150"/>
+            <a:off x="6048375" y="4324350"/>
             <a:ext cx="3143250" cy="1047750"/>
           </a:xfrm>
           <a:prstGeom xmlns:a="http://schemas.openxmlformats.org/drawingml/2006/main" prst="rect">
@@ -8861,7 +8861,7 @@
         </p:nvSpPr>
         <p:spPr>
           <a:xfrm xmlns:a="http://schemas.openxmlformats.org/drawingml/2006/main">
-            <a:off x="5619750" y="5286375"/>
+            <a:off x="5619750" y="5743575"/>
             <a:ext cx="4000500" cy="723900"/>
           </a:xfrm>
           <a:prstGeom xmlns:a="http://schemas.openxmlformats.org/drawingml/2006/main" prst="rect">
@@ -9043,7 +9043,7 @@
         </p:nvSpPr>
         <p:spPr>
           <a:xfrm xmlns:a="http://schemas.openxmlformats.org/drawingml/2006/main">
-            <a:off x="1066800" y="5762625"/>
+            <a:off x="1066800" y="6219825"/>
             <a:ext cx="4476750" cy="381000"/>
           </a:xfrm>
           <a:prstGeom xmlns:a="http://schemas.openxmlformats.org/drawingml/2006/main" prst="rect">
@@ -9202,7 +9202,7 @@
         </p:nvSpPr>
         <p:spPr>
           <a:xfrm xmlns:a="http://schemas.openxmlformats.org/drawingml/2006/main">
-            <a:off x="9696450" y="5762625"/>
+            <a:off x="9696450" y="6219825"/>
             <a:ext cx="4476750" cy="381000"/>
           </a:xfrm>
           <a:prstGeom xmlns:a="http://schemas.openxmlformats.org/drawingml/2006/main" prst="rect">
@@ -9419,7 +9419,7 @@
         <p:spPr>
           <a:xfrm xmlns:a="http://schemas.openxmlformats.org/drawingml/2006/main">
             <a:off x="1066800" y="733997"/>
-            <a:ext cx="1401961" cy="231458"/>
+            <a:ext cx="1057573" cy="231458"/>
           </a:xfrm>
           <a:prstGeom xmlns:a="http://schemas.openxmlformats.org/drawingml/2006/main" prst="rect">
             <a:avLst/>
@@ -9438,7 +9438,7 @@
             <a:defPPr algn="l">
               <a:defRPr sz="1350" b="0">
                 <a:solidFill>
-                  <a:srgbClr val="52627B"/>
+                  <a:srgbClr val="52627b"/>
                 </a:solidFill>
                 <a:latin typeface="Arial"/>
                 <a:ea typeface="Arial"/>
@@ -9448,7 +9448,7 @@
             <a:lvl1pPr algn="l">
               <a:defRPr sz="1350" b="0">
                 <a:solidFill>
-                  <a:srgbClr val="52627B"/>
+                  <a:srgbClr val="52627b"/>
                 </a:solidFill>
                 <a:latin typeface="Arial"/>
                 <a:ea typeface="Arial"/>
@@ -9458,7 +9458,7 @@
             <a:lvl2pPr algn="l">
               <a:defRPr sz="1350" b="0">
                 <a:solidFill>
-                  <a:srgbClr val="52627B"/>
+                  <a:srgbClr val="52627b"/>
                 </a:solidFill>
                 <a:latin typeface="Arial"/>
                 <a:ea typeface="Arial"/>
@@ -9468,7 +9468,7 @@
             <a:lvl3pPr algn="l">
               <a:defRPr sz="1350" b="0">
                 <a:solidFill>
-                  <a:srgbClr val="52627B"/>
+                  <a:srgbClr val="52627b"/>
                 </a:solidFill>
                 <a:latin typeface="Arial"/>
                 <a:ea typeface="Arial"/>
@@ -9478,7 +9478,7 @@
             <a:lvl4pPr algn="l">
               <a:defRPr sz="1350" b="0">
                 <a:solidFill>
-                  <a:srgbClr val="52627B"/>
+                  <a:srgbClr val="52627b"/>
                 </a:solidFill>
                 <a:latin typeface="Arial"/>
                 <a:ea typeface="Arial"/>
@@ -9488,7 +9488,7 @@
             <a:lvl5pPr algn="l">
               <a:defRPr sz="1350" b="0">
                 <a:solidFill>
-                  <a:srgbClr val="52627B"/>
+                  <a:srgbClr val="52627b"/>
                 </a:solidFill>
                 <a:latin typeface="Arial"/>
                 <a:ea typeface="Arial"/>
@@ -9498,7 +9498,7 @@
             <a:lvl6pPr algn="l">
               <a:defRPr sz="1350" b="0">
                 <a:solidFill>
-                  <a:srgbClr val="52627B"/>
+                  <a:srgbClr val="52627b"/>
                 </a:solidFill>
                 <a:latin typeface="Arial"/>
                 <a:ea typeface="Arial"/>
@@ -9508,7 +9508,7 @@
             <a:lvl7pPr algn="l">
               <a:defRPr sz="1350" b="0">
                 <a:solidFill>
-                  <a:srgbClr val="52627B"/>
+                  <a:srgbClr val="52627b"/>
                 </a:solidFill>
                 <a:latin typeface="Arial"/>
                 <a:ea typeface="Arial"/>
@@ -9518,7 +9518,7 @@
             <a:lvl8pPr algn="l">
               <a:defRPr sz="1350" b="0">
                 <a:solidFill>
-                  <a:srgbClr val="52627B"/>
+                  <a:srgbClr val="52627b"/>
                 </a:solidFill>
                 <a:latin typeface="Arial"/>
                 <a:ea typeface="Arial"/>
@@ -9528,7 +9528,7 @@
             <a:lvl9pPr algn="l">
               <a:defRPr sz="1350" b="0">
                 <a:solidFill>
-                  <a:srgbClr val="52627B"/>
+                  <a:srgbClr val="52627b"/>
                 </a:solidFill>
                 <a:latin typeface="Arial"/>
                 <a:ea typeface="Arial"/>
@@ -9540,7 +9540,7 @@
             <a:pPr algn="l">
               <a:defRPr sz="1350" b="0">
                 <a:solidFill>
-                  <a:srgbClr val="52627B"/>
+                  <a:srgbClr val="52627b"/>
                 </a:solidFill>
                 <a:latin typeface="Arial"/>
                 <a:ea typeface="Arial"/>
@@ -9550,13 +9550,13 @@
             <a:r>
               <a:rPr sz="1350" b="0">
                 <a:solidFill>
-                  <a:srgbClr val="52627B"/>
+                  <a:srgbClr val="52627b"/>
                 </a:solidFill>
                 <a:latin typeface="Arial"/>
                 <a:ea typeface="Arial"/>
                 <a:cs typeface="Arial"/>
               </a:rPr>
-              <a:t>INTRODUZIONE</a:t>
+              <a:t>PROBLEMA</a:t>
             </a:r>
           </a:p>
         </p:txBody>
@@ -9597,7 +9597,7 @@
             <a:defPPr algn="l">
               <a:defRPr sz="1350" b="0">
                 <a:solidFill>
-                  <a:srgbClr val="52627B"/>
+                  <a:srgbClr val="52627b"/>
                 </a:solidFill>
                 <a:latin typeface="Arial"/>
                 <a:ea typeface="Arial"/>
@@ -9607,7 +9607,7 @@
             <a:lvl1pPr algn="l">
               <a:defRPr sz="1350" b="0">
                 <a:solidFill>
-                  <a:srgbClr val="52627B"/>
+                  <a:srgbClr val="52627b"/>
                 </a:solidFill>
                 <a:latin typeface="Arial"/>
                 <a:ea typeface="Arial"/>
@@ -9617,7 +9617,7 @@
             <a:lvl2pPr algn="l">
               <a:defRPr sz="1350" b="0">
                 <a:solidFill>
-                  <a:srgbClr val="52627B"/>
+                  <a:srgbClr val="52627b"/>
                 </a:solidFill>
                 <a:latin typeface="Arial"/>
                 <a:ea typeface="Arial"/>
@@ -9627,7 +9627,7 @@
             <a:lvl3pPr algn="l">
               <a:defRPr sz="1350" b="0">
                 <a:solidFill>
-                  <a:srgbClr val="52627B"/>
+                  <a:srgbClr val="52627b"/>
                 </a:solidFill>
                 <a:latin typeface="Arial"/>
                 <a:ea typeface="Arial"/>
@@ -9637,7 +9637,7 @@
             <a:lvl4pPr algn="l">
               <a:defRPr sz="1350" b="0">
                 <a:solidFill>
-                  <a:srgbClr val="52627B"/>
+                  <a:srgbClr val="52627b"/>
                 </a:solidFill>
                 <a:latin typeface="Arial"/>
                 <a:ea typeface="Arial"/>
@@ -9647,7 +9647,7 @@
             <a:lvl5pPr algn="l">
               <a:defRPr sz="1350" b="0">
                 <a:solidFill>
-                  <a:srgbClr val="52627B"/>
+                  <a:srgbClr val="52627b"/>
                 </a:solidFill>
                 <a:latin typeface="Arial"/>
                 <a:ea typeface="Arial"/>
@@ -9657,7 +9657,7 @@
             <a:lvl6pPr algn="l">
               <a:defRPr sz="1350" b="0">
                 <a:solidFill>
-                  <a:srgbClr val="52627B"/>
+                  <a:srgbClr val="52627b"/>
                 </a:solidFill>
                 <a:latin typeface="Arial"/>
                 <a:ea typeface="Arial"/>
@@ -9667,7 +9667,7 @@
             <a:lvl7pPr algn="l">
               <a:defRPr sz="1350" b="0">
                 <a:solidFill>
-                  <a:srgbClr val="52627B"/>
+                  <a:srgbClr val="52627b"/>
                 </a:solidFill>
                 <a:latin typeface="Arial"/>
                 <a:ea typeface="Arial"/>
@@ -9677,7 +9677,7 @@
             <a:lvl8pPr algn="l">
               <a:defRPr sz="1350" b="0">
                 <a:solidFill>
-                  <a:srgbClr val="52627B"/>
+                  <a:srgbClr val="52627b"/>
                 </a:solidFill>
                 <a:latin typeface="Arial"/>
                 <a:ea typeface="Arial"/>
@@ -9687,7 +9687,7 @@
             <a:lvl9pPr algn="l">
               <a:defRPr sz="1350" b="0">
                 <a:solidFill>
-                  <a:srgbClr val="52627B"/>
+                  <a:srgbClr val="52627b"/>
                 </a:solidFill>
                 <a:latin typeface="Arial"/>
                 <a:ea typeface="Arial"/>
@@ -9699,7 +9699,7 @@
             <a:pPr algn="l">
               <a:defRPr sz="1350" b="0">
                 <a:solidFill>
-                  <a:srgbClr val="52627B"/>
+                  <a:srgbClr val="52627b"/>
                 </a:solidFill>
                 <a:latin typeface="Arial"/>
                 <a:ea typeface="Arial"/>
@@ -9709,7 +9709,7 @@
             <a:r>
               <a:rPr sz="1350" b="0">
                 <a:solidFill>
-                  <a:srgbClr val="52627B"/>
+                  <a:srgbClr val="52627b"/>
                 </a:solidFill>
                 <a:latin typeface="Arial"/>
                 <a:ea typeface="Arial"/>
@@ -9896,7 +9896,7 @@
         <p:spPr>
           <a:xfrm xmlns:a="http://schemas.openxmlformats.org/drawingml/2006/main">
             <a:off x="1066800" y="1901095"/>
-            <a:ext cx="12059096" cy="347186"/>
+            <a:ext cx="10108406" cy="347186"/>
           </a:xfrm>
           <a:prstGeom xmlns:a="http://schemas.openxmlformats.org/drawingml/2006/main" prst="rect">
             <a:avLst/>
@@ -9915,7 +9915,7 @@
             <a:defPPr algn="l">
               <a:defRPr sz="2025" b="0">
                 <a:solidFill>
-                  <a:srgbClr val="52627B"/>
+                  <a:srgbClr val="52627b"/>
                 </a:solidFill>
                 <a:latin typeface="Arial"/>
                 <a:ea typeface="Arial"/>
@@ -9925,7 +9925,7 @@
             <a:lvl1pPr algn="l">
               <a:defRPr sz="2025" b="0">
                 <a:solidFill>
-                  <a:srgbClr val="52627B"/>
+                  <a:srgbClr val="52627b"/>
                 </a:solidFill>
                 <a:latin typeface="Arial"/>
                 <a:ea typeface="Arial"/>
@@ -9935,7 +9935,7 @@
             <a:lvl2pPr algn="l">
               <a:defRPr sz="2025" b="0">
                 <a:solidFill>
-                  <a:srgbClr val="52627B"/>
+                  <a:srgbClr val="52627b"/>
                 </a:solidFill>
                 <a:latin typeface="Arial"/>
                 <a:ea typeface="Arial"/>
@@ -9945,7 +9945,7 @@
             <a:lvl3pPr algn="l">
               <a:defRPr sz="2025" b="0">
                 <a:solidFill>
-                  <a:srgbClr val="52627B"/>
+                  <a:srgbClr val="52627b"/>
                 </a:solidFill>
                 <a:latin typeface="Arial"/>
                 <a:ea typeface="Arial"/>
@@ -9955,7 +9955,7 @@
             <a:lvl4pPr algn="l">
               <a:defRPr sz="2025" b="0">
                 <a:solidFill>
-                  <a:srgbClr val="52627B"/>
+                  <a:srgbClr val="52627b"/>
                 </a:solidFill>
                 <a:latin typeface="Arial"/>
                 <a:ea typeface="Arial"/>
@@ -9965,7 +9965,7 @@
             <a:lvl5pPr algn="l">
               <a:defRPr sz="2025" b="0">
                 <a:solidFill>
-                  <a:srgbClr val="52627B"/>
+                  <a:srgbClr val="52627b"/>
                 </a:solidFill>
                 <a:latin typeface="Arial"/>
                 <a:ea typeface="Arial"/>
@@ -9975,7 +9975,7 @@
             <a:lvl6pPr algn="l">
               <a:defRPr sz="2025" b="0">
                 <a:solidFill>
-                  <a:srgbClr val="52627B"/>
+                  <a:srgbClr val="52627b"/>
                 </a:solidFill>
                 <a:latin typeface="Arial"/>
                 <a:ea typeface="Arial"/>
@@ -9985,7 +9985,7 @@
             <a:lvl7pPr algn="l">
               <a:defRPr sz="2025" b="0">
                 <a:solidFill>
-                  <a:srgbClr val="52627B"/>
+                  <a:srgbClr val="52627b"/>
                 </a:solidFill>
                 <a:latin typeface="Arial"/>
                 <a:ea typeface="Arial"/>
@@ -9995,7 +9995,7 @@
             <a:lvl8pPr algn="l">
               <a:defRPr sz="2025" b="0">
                 <a:solidFill>
-                  <a:srgbClr val="52627B"/>
+                  <a:srgbClr val="52627b"/>
                 </a:solidFill>
                 <a:latin typeface="Arial"/>
                 <a:ea typeface="Arial"/>
@@ -10005,7 +10005,7 @@
             <a:lvl9pPr algn="l">
               <a:defRPr sz="2025" b="0">
                 <a:solidFill>
-                  <a:srgbClr val="52627B"/>
+                  <a:srgbClr val="52627b"/>
                 </a:solidFill>
                 <a:latin typeface="Arial"/>
                 <a:ea typeface="Arial"/>
@@ -10017,7 +10017,7 @@
             <a:pPr algn="l">
               <a:defRPr sz="2025" b="0">
                 <a:solidFill>
-                  <a:srgbClr val="52627B"/>
+                  <a:srgbClr val="52627b"/>
                 </a:solidFill>
                 <a:latin typeface="Arial"/>
                 <a:ea typeface="Arial"/>
@@ -10027,13 +10027,13 @@
             <a:r>
               <a:rPr sz="2025" b="0">
                 <a:solidFill>
-                  <a:srgbClr val="52627B"/>
+                  <a:srgbClr val="52627b"/>
                 </a:solidFill>
                 <a:latin typeface="Arial"/>
                 <a:ea typeface="Arial"/>
                 <a:cs typeface="Arial"/>
               </a:rPr>
-              <a:t>Nel 5G, la sicurezza riguarda anche le Network Functions, componenti software che comunicano tra loro.</a:t>
+              <a:t>Nel 5G, la sicurezza viene valutata tramite le Security Assurance Specification, o SCAS.</a:t>
             </a:r>
           </a:p>
         </p:txBody>
@@ -10074,7 +10074,7 @@
             <a:defPPr algn="l">
               <a:defRPr sz="2478" b="1">
                 <a:solidFill>
-                  <a:srgbClr val="4264D0"/>
+                  <a:srgbClr val="a0b1e6"/>
                 </a:solidFill>
                 <a:latin typeface="Arial"/>
                 <a:ea typeface="Arial"/>
@@ -10084,7 +10084,7 @@
             <a:lvl1pPr algn="l">
               <a:defRPr sz="2478" b="1">
                 <a:solidFill>
-                  <a:srgbClr val="4264D0"/>
+                  <a:srgbClr val="a0b1e6"/>
                 </a:solidFill>
                 <a:latin typeface="Arial"/>
                 <a:ea typeface="Arial"/>
@@ -10094,7 +10094,7 @@
             <a:lvl2pPr algn="l">
               <a:defRPr sz="2478" b="1">
                 <a:solidFill>
-                  <a:srgbClr val="4264D0"/>
+                  <a:srgbClr val="a0b1e6"/>
                 </a:solidFill>
                 <a:latin typeface="Arial"/>
                 <a:ea typeface="Arial"/>
@@ -10104,7 +10104,7 @@
             <a:lvl3pPr algn="l">
               <a:defRPr sz="2478" b="1">
                 <a:solidFill>
-                  <a:srgbClr val="4264D0"/>
+                  <a:srgbClr val="a0b1e6"/>
                 </a:solidFill>
                 <a:latin typeface="Arial"/>
                 <a:ea typeface="Arial"/>
@@ -10114,7 +10114,7 @@
             <a:lvl4pPr algn="l">
               <a:defRPr sz="2478" b="1">
                 <a:solidFill>
-                  <a:srgbClr val="4264D0"/>
+                  <a:srgbClr val="a0b1e6"/>
                 </a:solidFill>
                 <a:latin typeface="Arial"/>
                 <a:ea typeface="Arial"/>
@@ -10124,7 +10124,7 @@
             <a:lvl5pPr algn="l">
               <a:defRPr sz="2478" b="1">
                 <a:solidFill>
-                  <a:srgbClr val="4264D0"/>
+                  <a:srgbClr val="a0b1e6"/>
                 </a:solidFill>
                 <a:latin typeface="Arial"/>
                 <a:ea typeface="Arial"/>
@@ -10134,7 +10134,7 @@
             <a:lvl6pPr algn="l">
               <a:defRPr sz="2478" b="1">
                 <a:solidFill>
-                  <a:srgbClr val="4264D0"/>
+                  <a:srgbClr val="a0b1e6"/>
                 </a:solidFill>
                 <a:latin typeface="Arial"/>
                 <a:ea typeface="Arial"/>
@@ -10144,7 +10144,7 @@
             <a:lvl7pPr algn="l">
               <a:defRPr sz="2478" b="1">
                 <a:solidFill>
-                  <a:srgbClr val="4264D0"/>
+                  <a:srgbClr val="a0b1e6"/>
                 </a:solidFill>
                 <a:latin typeface="Arial"/>
                 <a:ea typeface="Arial"/>
@@ -10154,7 +10154,7 @@
             <a:lvl8pPr algn="l">
               <a:defRPr sz="2478" b="1">
                 <a:solidFill>
-                  <a:srgbClr val="4264D0"/>
+                  <a:srgbClr val="a0b1e6"/>
                 </a:solidFill>
                 <a:latin typeface="Arial"/>
                 <a:ea typeface="Arial"/>
@@ -10164,7 +10164,7 @@
             <a:lvl9pPr algn="l">
               <a:defRPr sz="2478" b="1">
                 <a:solidFill>
-                  <a:srgbClr val="4264D0"/>
+                  <a:srgbClr val="a0b1e6"/>
                 </a:solidFill>
                 <a:latin typeface="Arial"/>
                 <a:ea typeface="Arial"/>
@@ -10176,7 +10176,7 @@
             <a:pPr algn="l">
               <a:defRPr sz="2478" b="1">
                 <a:solidFill>
-                  <a:srgbClr val="4264D0"/>
+                  <a:srgbClr val="a0b1e6"/>
                 </a:solidFill>
                 <a:latin typeface="Arial"/>
                 <a:ea typeface="Arial"/>
@@ -10186,7 +10186,7 @@
             <a:r>
               <a:rPr sz="2478" b="1">
                 <a:solidFill>
-                  <a:srgbClr val="4264D0"/>
+                  <a:srgbClr val="a0b1e6"/>
                 </a:solidFill>
                 <a:latin typeface="Arial"/>
                 <a:ea typeface="Arial"/>
@@ -10551,7 +10551,7 @@
             <a:defPPr algn="l">
               <a:defRPr sz="1858" b="1">
                 <a:solidFill>
-                  <a:srgbClr val="7861AD"/>
+                  <a:srgbClr val="7861ad"/>
                 </a:solidFill>
                 <a:latin typeface="Arial"/>
                 <a:ea typeface="Arial"/>
@@ -10561,7 +10561,7 @@
             <a:lvl1pPr algn="l">
               <a:defRPr sz="1858" b="1">
                 <a:solidFill>
-                  <a:srgbClr val="7861AD"/>
+                  <a:srgbClr val="7861ad"/>
                 </a:solidFill>
                 <a:latin typeface="Arial"/>
                 <a:ea typeface="Arial"/>
@@ -10571,7 +10571,7 @@
             <a:lvl2pPr algn="l">
               <a:defRPr sz="1858" b="1">
                 <a:solidFill>
-                  <a:srgbClr val="7861AD"/>
+                  <a:srgbClr val="7861ad"/>
                 </a:solidFill>
                 <a:latin typeface="Arial"/>
                 <a:ea typeface="Arial"/>
@@ -10581,7 +10581,7 @@
             <a:lvl3pPr algn="l">
               <a:defRPr sz="1858" b="1">
                 <a:solidFill>
-                  <a:srgbClr val="7861AD"/>
+                  <a:srgbClr val="7861ad"/>
                 </a:solidFill>
                 <a:latin typeface="Arial"/>
                 <a:ea typeface="Arial"/>
@@ -10591,7 +10591,7 @@
             <a:lvl4pPr algn="l">
               <a:defRPr sz="1858" b="1">
                 <a:solidFill>
-                  <a:srgbClr val="7861AD"/>
+                  <a:srgbClr val="7861ad"/>
                 </a:solidFill>
                 <a:latin typeface="Arial"/>
                 <a:ea typeface="Arial"/>
@@ -10601,7 +10601,7 @@
             <a:lvl5pPr algn="l">
               <a:defRPr sz="1858" b="1">
                 <a:solidFill>
-                  <a:srgbClr val="7861AD"/>
+                  <a:srgbClr val="7861ad"/>
                 </a:solidFill>
                 <a:latin typeface="Arial"/>
                 <a:ea typeface="Arial"/>
@@ -10611,7 +10611,7 @@
             <a:lvl6pPr algn="l">
               <a:defRPr sz="1858" b="1">
                 <a:solidFill>
-                  <a:srgbClr val="7861AD"/>
+                  <a:srgbClr val="7861ad"/>
                 </a:solidFill>
                 <a:latin typeface="Arial"/>
                 <a:ea typeface="Arial"/>
@@ -10621,7 +10621,7 @@
             <a:lvl7pPr algn="l">
               <a:defRPr sz="1858" b="1">
                 <a:solidFill>
-                  <a:srgbClr val="7861AD"/>
+                  <a:srgbClr val="7861ad"/>
                 </a:solidFill>
                 <a:latin typeface="Arial"/>
                 <a:ea typeface="Arial"/>
@@ -10631,7 +10631,7 @@
             <a:lvl8pPr algn="l">
               <a:defRPr sz="1858" b="1">
                 <a:solidFill>
-                  <a:srgbClr val="7861AD"/>
+                  <a:srgbClr val="7861ad"/>
                 </a:solidFill>
                 <a:latin typeface="Arial"/>
                 <a:ea typeface="Arial"/>
@@ -10641,7 +10641,7 @@
             <a:lvl9pPr algn="l">
               <a:defRPr sz="1858" b="1">
                 <a:solidFill>
-                  <a:srgbClr val="7861AD"/>
+                  <a:srgbClr val="7861ad"/>
                 </a:solidFill>
                 <a:latin typeface="Arial"/>
                 <a:ea typeface="Arial"/>
@@ -10653,7 +10653,7 @@
             <a:pPr algn="l">
               <a:defRPr sz="1858" b="1">
                 <a:solidFill>
-                  <a:srgbClr val="7861AD"/>
+                  <a:srgbClr val="7861ad"/>
                 </a:solidFill>
                 <a:latin typeface="Arial"/>
                 <a:ea typeface="Arial"/>
@@ -10663,7 +10663,7 @@
             <a:r>
               <a:rPr sz="1858" b="1">
                 <a:solidFill>
-                  <a:srgbClr val="7861AD"/>
+                  <a:srgbClr val="7861ad"/>
                 </a:solidFill>
                 <a:latin typeface="Arial"/>
                 <a:ea typeface="Arial"/>
@@ -11346,7 +11346,7 @@
             <a:defPPr algn="l">
               <a:defRPr sz="2478" b="1">
                 <a:solidFill>
-                  <a:srgbClr val="7861AD"/>
+                  <a:srgbClr val="7861ad"/>
                 </a:solidFill>
                 <a:latin typeface="Arial"/>
                 <a:ea typeface="Arial"/>
@@ -11356,7 +11356,7 @@
             <a:lvl1pPr algn="l">
               <a:defRPr sz="2478" b="1">
                 <a:solidFill>
-                  <a:srgbClr val="7861AD"/>
+                  <a:srgbClr val="7861ad"/>
                 </a:solidFill>
                 <a:latin typeface="Arial"/>
                 <a:ea typeface="Arial"/>
@@ -11366,7 +11366,7 @@
             <a:lvl2pPr algn="l">
               <a:defRPr sz="2478" b="1">
                 <a:solidFill>
-                  <a:srgbClr val="7861AD"/>
+                  <a:srgbClr val="7861ad"/>
                 </a:solidFill>
                 <a:latin typeface="Arial"/>
                 <a:ea typeface="Arial"/>
@@ -11376,7 +11376,7 @@
             <a:lvl3pPr algn="l">
               <a:defRPr sz="2478" b="1">
                 <a:solidFill>
-                  <a:srgbClr val="7861AD"/>
+                  <a:srgbClr val="7861ad"/>
                 </a:solidFill>
                 <a:latin typeface="Arial"/>
                 <a:ea typeface="Arial"/>
@@ -11386,7 +11386,7 @@
             <a:lvl4pPr algn="l">
               <a:defRPr sz="2478" b="1">
                 <a:solidFill>
-                  <a:srgbClr val="7861AD"/>
+                  <a:srgbClr val="7861ad"/>
                 </a:solidFill>
                 <a:latin typeface="Arial"/>
                 <a:ea typeface="Arial"/>
@@ -11396,7 +11396,7 @@
             <a:lvl5pPr algn="l">
               <a:defRPr sz="2478" b="1">
                 <a:solidFill>
-                  <a:srgbClr val="7861AD"/>
+                  <a:srgbClr val="7861ad"/>
                 </a:solidFill>
                 <a:latin typeface="Arial"/>
                 <a:ea typeface="Arial"/>
@@ -11406,7 +11406,7 @@
             <a:lvl6pPr algn="l">
               <a:defRPr sz="2478" b="1">
                 <a:solidFill>
-                  <a:srgbClr val="7861AD"/>
+                  <a:srgbClr val="7861ad"/>
                 </a:solidFill>
                 <a:latin typeface="Arial"/>
                 <a:ea typeface="Arial"/>
@@ -11416,7 +11416,7 @@
             <a:lvl7pPr algn="l">
               <a:defRPr sz="2478" b="1">
                 <a:solidFill>
-                  <a:srgbClr val="7861AD"/>
+                  <a:srgbClr val="7861ad"/>
                 </a:solidFill>
                 <a:latin typeface="Arial"/>
                 <a:ea typeface="Arial"/>
@@ -11426,7 +11426,7 @@
             <a:lvl8pPr algn="l">
               <a:defRPr sz="2478" b="1">
                 <a:solidFill>
-                  <a:srgbClr val="7861AD"/>
+                  <a:srgbClr val="7861ad"/>
                 </a:solidFill>
                 <a:latin typeface="Arial"/>
                 <a:ea typeface="Arial"/>
@@ -11436,7 +11436,7 @@
             <a:lvl9pPr algn="l">
               <a:defRPr sz="2478" b="1">
                 <a:solidFill>
-                  <a:srgbClr val="7861AD"/>
+                  <a:srgbClr val="7861ad"/>
                 </a:solidFill>
                 <a:latin typeface="Arial"/>
                 <a:ea typeface="Arial"/>
@@ -11448,7 +11448,7 @@
             <a:pPr algn="l">
               <a:defRPr sz="2478" b="1">
                 <a:solidFill>
-                  <a:srgbClr val="7861AD"/>
+                  <a:srgbClr val="7861ad"/>
                 </a:solidFill>
                 <a:latin typeface="Arial"/>
                 <a:ea typeface="Arial"/>
@@ -11458,7 +11458,7 @@
             <a:r>
               <a:rPr sz="2478" b="1">
                 <a:solidFill>
-                  <a:srgbClr val="7861AD"/>
+                  <a:srgbClr val="7861ad"/>
                 </a:solidFill>
                 <a:latin typeface="Arial"/>
                 <a:ea typeface="Arial"/>
@@ -11823,7 +11823,7 @@
             <a:defPPr algn="l">
               <a:defRPr sz="2213" b="1">
                 <a:solidFill>
-                  <a:srgbClr val="1C2A40"/>
+                  <a:srgbClr val="8e96a2"/>
                 </a:solidFill>
                 <a:latin typeface="Arial"/>
                 <a:ea typeface="Arial"/>
@@ -11833,7 +11833,7 @@
             <a:lvl1pPr algn="l">
               <a:defRPr sz="2213" b="1">
                 <a:solidFill>
-                  <a:srgbClr val="1C2A40"/>
+                  <a:srgbClr val="8e96a2"/>
                 </a:solidFill>
                 <a:latin typeface="Arial"/>
                 <a:ea typeface="Arial"/>
@@ -11843,7 +11843,7 @@
             <a:lvl2pPr algn="l">
               <a:defRPr sz="2213" b="1">
                 <a:solidFill>
-                  <a:srgbClr val="1C2A40"/>
+                  <a:srgbClr val="8e96a2"/>
                 </a:solidFill>
                 <a:latin typeface="Arial"/>
                 <a:ea typeface="Arial"/>
@@ -11853,7 +11853,7 @@
             <a:lvl3pPr algn="l">
               <a:defRPr sz="2213" b="1">
                 <a:solidFill>
-                  <a:srgbClr val="1C2A40"/>
+                  <a:srgbClr val="8e96a2"/>
                 </a:solidFill>
                 <a:latin typeface="Arial"/>
                 <a:ea typeface="Arial"/>
@@ -11863,7 +11863,7 @@
             <a:lvl4pPr algn="l">
               <a:defRPr sz="2213" b="1">
                 <a:solidFill>
-                  <a:srgbClr val="1C2A40"/>
+                  <a:srgbClr val="8e96a2"/>
                 </a:solidFill>
                 <a:latin typeface="Arial"/>
                 <a:ea typeface="Arial"/>
@@ -11873,7 +11873,7 @@
             <a:lvl5pPr algn="l">
               <a:defRPr sz="2213" b="1">
                 <a:solidFill>
-                  <a:srgbClr val="1C2A40"/>
+                  <a:srgbClr val="8e96a2"/>
                 </a:solidFill>
                 <a:latin typeface="Arial"/>
                 <a:ea typeface="Arial"/>
@@ -11883,7 +11883,7 @@
             <a:lvl6pPr algn="l">
               <a:defRPr sz="2213" b="1">
                 <a:solidFill>
-                  <a:srgbClr val="1C2A40"/>
+                  <a:srgbClr val="8e96a2"/>
                 </a:solidFill>
                 <a:latin typeface="Arial"/>
                 <a:ea typeface="Arial"/>
@@ -11893,7 +11893,7 @@
             <a:lvl7pPr algn="l">
               <a:defRPr sz="2213" b="1">
                 <a:solidFill>
-                  <a:srgbClr val="1C2A40"/>
+                  <a:srgbClr val="8e96a2"/>
                 </a:solidFill>
                 <a:latin typeface="Arial"/>
                 <a:ea typeface="Arial"/>
@@ -11903,7 +11903,7 @@
             <a:lvl8pPr algn="l">
               <a:defRPr sz="2213" b="1">
                 <a:solidFill>
-                  <a:srgbClr val="1C2A40"/>
+                  <a:srgbClr val="8e96a2"/>
                 </a:solidFill>
                 <a:latin typeface="Arial"/>
                 <a:ea typeface="Arial"/>
@@ -11913,7 +11913,7 @@
             <a:lvl9pPr algn="l">
               <a:defRPr sz="2213" b="1">
                 <a:solidFill>
-                  <a:srgbClr val="1C2A40"/>
+                  <a:srgbClr val="8e96a2"/>
                 </a:solidFill>
                 <a:latin typeface="Arial"/>
                 <a:ea typeface="Arial"/>
@@ -11925,7 +11925,7 @@
             <a:pPr algn="l">
               <a:defRPr sz="2213" b="1">
                 <a:solidFill>
-                  <a:srgbClr val="1C2A40"/>
+                  <a:srgbClr val="8e96a2"/>
                 </a:solidFill>
                 <a:latin typeface="Arial"/>
                 <a:ea typeface="Arial"/>
@@ -11935,7 +11935,7 @@
             <a:r>
               <a:rPr sz="2213" b="1">
                 <a:solidFill>
-                  <a:srgbClr val="1C2A40"/>
+                  <a:srgbClr val="8e96a2"/>
                 </a:solidFill>
                 <a:latin typeface="Arial"/>
                 <a:ea typeface="Arial"/>
@@ -11982,7 +11982,7 @@
             <a:defPPr algn="l">
               <a:defRPr sz="2213" b="1">
                 <a:solidFill>
-                  <a:srgbClr val="1C2A40"/>
+                  <a:srgbClr val="8e96a2"/>
                 </a:solidFill>
                 <a:latin typeface="Arial"/>
                 <a:ea typeface="Arial"/>
@@ -11992,7 +11992,7 @@
             <a:lvl1pPr algn="l">
               <a:defRPr sz="2213" b="1">
                 <a:solidFill>
-                  <a:srgbClr val="1C2A40"/>
+                  <a:srgbClr val="8e96a2"/>
                 </a:solidFill>
                 <a:latin typeface="Arial"/>
                 <a:ea typeface="Arial"/>
@@ -12002,7 +12002,7 @@
             <a:lvl2pPr algn="l">
               <a:defRPr sz="2213" b="1">
                 <a:solidFill>
-                  <a:srgbClr val="1C2A40"/>
+                  <a:srgbClr val="8e96a2"/>
                 </a:solidFill>
                 <a:latin typeface="Arial"/>
                 <a:ea typeface="Arial"/>
@@ -12012,7 +12012,7 @@
             <a:lvl3pPr algn="l">
               <a:defRPr sz="2213" b="1">
                 <a:solidFill>
-                  <a:srgbClr val="1C2A40"/>
+                  <a:srgbClr val="8e96a2"/>
                 </a:solidFill>
                 <a:latin typeface="Arial"/>
                 <a:ea typeface="Arial"/>
@@ -12022,7 +12022,7 @@
             <a:lvl4pPr algn="l">
               <a:defRPr sz="2213" b="1">
                 <a:solidFill>
-                  <a:srgbClr val="1C2A40"/>
+                  <a:srgbClr val="8e96a2"/>
                 </a:solidFill>
                 <a:latin typeface="Arial"/>
                 <a:ea typeface="Arial"/>
@@ -12032,7 +12032,7 @@
             <a:lvl5pPr algn="l">
               <a:defRPr sz="2213" b="1">
                 <a:solidFill>
-                  <a:srgbClr val="1C2A40"/>
+                  <a:srgbClr val="8e96a2"/>
                 </a:solidFill>
                 <a:latin typeface="Arial"/>
                 <a:ea typeface="Arial"/>
@@ -12042,7 +12042,7 @@
             <a:lvl6pPr algn="l">
               <a:defRPr sz="2213" b="1">
                 <a:solidFill>
-                  <a:srgbClr val="1C2A40"/>
+                  <a:srgbClr val="8e96a2"/>
                 </a:solidFill>
                 <a:latin typeface="Arial"/>
                 <a:ea typeface="Arial"/>
@@ -12052,7 +12052,7 @@
             <a:lvl7pPr algn="l">
               <a:defRPr sz="2213" b="1">
                 <a:solidFill>
-                  <a:srgbClr val="1C2A40"/>
+                  <a:srgbClr val="8e96a2"/>
                 </a:solidFill>
                 <a:latin typeface="Arial"/>
                 <a:ea typeface="Arial"/>
@@ -12062,7 +12062,7 @@
             <a:lvl8pPr algn="l">
               <a:defRPr sz="2213" b="1">
                 <a:solidFill>
-                  <a:srgbClr val="1C2A40"/>
+                  <a:srgbClr val="8e96a2"/>
                 </a:solidFill>
                 <a:latin typeface="Arial"/>
                 <a:ea typeface="Arial"/>
@@ -12072,7 +12072,7 @@
             <a:lvl9pPr algn="l">
               <a:defRPr sz="2213" b="1">
                 <a:solidFill>
-                  <a:srgbClr val="1C2A40"/>
+                  <a:srgbClr val="8e96a2"/>
                 </a:solidFill>
                 <a:latin typeface="Arial"/>
                 <a:ea typeface="Arial"/>
@@ -12084,7 +12084,7 @@
             <a:pPr algn="l">
               <a:defRPr sz="2213" b="1">
                 <a:solidFill>
-                  <a:srgbClr val="1C2A40"/>
+                  <a:srgbClr val="8e96a2"/>
                 </a:solidFill>
                 <a:latin typeface="Arial"/>
                 <a:ea typeface="Arial"/>
@@ -12094,7 +12094,7 @@
             <a:r>
               <a:rPr sz="2213" b="1">
                 <a:solidFill>
-                  <a:srgbClr val="1C2A40"/>
+                  <a:srgbClr val="8e96a2"/>
                 </a:solidFill>
                 <a:latin typeface="Arial"/>
                 <a:ea typeface="Arial"/>
@@ -12141,7 +12141,7 @@
             <a:defPPr algn="l">
               <a:defRPr sz="1858" b="1">
                 <a:solidFill>
-                  <a:srgbClr val="278766"/>
+                  <a:srgbClr val="93c2b4"/>
                 </a:solidFill>
                 <a:latin typeface="Arial"/>
                 <a:ea typeface="Arial"/>
@@ -12151,7 +12151,7 @@
             <a:lvl1pPr algn="l">
               <a:defRPr sz="1858" b="1">
                 <a:solidFill>
-                  <a:srgbClr val="278766"/>
+                  <a:srgbClr val="93c2b4"/>
                 </a:solidFill>
                 <a:latin typeface="Arial"/>
                 <a:ea typeface="Arial"/>
@@ -12161,7 +12161,7 @@
             <a:lvl2pPr algn="l">
               <a:defRPr sz="1858" b="1">
                 <a:solidFill>
-                  <a:srgbClr val="278766"/>
+                  <a:srgbClr val="93c2b4"/>
                 </a:solidFill>
                 <a:latin typeface="Arial"/>
                 <a:ea typeface="Arial"/>
@@ -12171,7 +12171,7 @@
             <a:lvl3pPr algn="l">
               <a:defRPr sz="1858" b="1">
                 <a:solidFill>
-                  <a:srgbClr val="278766"/>
+                  <a:srgbClr val="93c2b4"/>
                 </a:solidFill>
                 <a:latin typeface="Arial"/>
                 <a:ea typeface="Arial"/>
@@ -12181,7 +12181,7 @@
             <a:lvl4pPr algn="l">
               <a:defRPr sz="1858" b="1">
                 <a:solidFill>
-                  <a:srgbClr val="278766"/>
+                  <a:srgbClr val="93c2b4"/>
                 </a:solidFill>
                 <a:latin typeface="Arial"/>
                 <a:ea typeface="Arial"/>
@@ -12191,7 +12191,7 @@
             <a:lvl5pPr algn="l">
               <a:defRPr sz="1858" b="1">
                 <a:solidFill>
-                  <a:srgbClr val="278766"/>
+                  <a:srgbClr val="93c2b4"/>
                 </a:solidFill>
                 <a:latin typeface="Arial"/>
                 <a:ea typeface="Arial"/>
@@ -12201,7 +12201,7 @@
             <a:lvl6pPr algn="l">
               <a:defRPr sz="1858" b="1">
                 <a:solidFill>
-                  <a:srgbClr val="278766"/>
+                  <a:srgbClr val="93c2b4"/>
                 </a:solidFill>
                 <a:latin typeface="Arial"/>
                 <a:ea typeface="Arial"/>
@@ -12211,7 +12211,7 @@
             <a:lvl7pPr algn="l">
               <a:defRPr sz="1858" b="1">
                 <a:solidFill>
-                  <a:srgbClr val="278766"/>
+                  <a:srgbClr val="93c2b4"/>
                 </a:solidFill>
                 <a:latin typeface="Arial"/>
                 <a:ea typeface="Arial"/>
@@ -12221,7 +12221,7 @@
             <a:lvl8pPr algn="l">
               <a:defRPr sz="1858" b="1">
                 <a:solidFill>
-                  <a:srgbClr val="278766"/>
+                  <a:srgbClr val="93c2b4"/>
                 </a:solidFill>
                 <a:latin typeface="Arial"/>
                 <a:ea typeface="Arial"/>
@@ -12231,7 +12231,7 @@
             <a:lvl9pPr algn="l">
               <a:defRPr sz="1858" b="1">
                 <a:solidFill>
-                  <a:srgbClr val="278766"/>
+                  <a:srgbClr val="93c2b4"/>
                 </a:solidFill>
                 <a:latin typeface="Arial"/>
                 <a:ea typeface="Arial"/>
@@ -12243,7 +12243,7 @@
             <a:pPr algn="l">
               <a:defRPr sz="1858" b="1">
                 <a:solidFill>
-                  <a:srgbClr val="278766"/>
+                  <a:srgbClr val="93c2b4"/>
                 </a:solidFill>
                 <a:latin typeface="Arial"/>
                 <a:ea typeface="Arial"/>
@@ -12253,7 +12253,7 @@
             <a:r>
               <a:rPr sz="1858" b="1">
                 <a:solidFill>
-                  <a:srgbClr val="278766"/>
+                  <a:srgbClr val="93c2b4"/>
                 </a:solidFill>
                 <a:latin typeface="Arial"/>
                 <a:ea typeface="Arial"/>
@@ -12300,7 +12300,7 @@
             <a:defPPr algn="l">
               <a:defRPr sz="1858" b="1">
                 <a:solidFill>
-                  <a:srgbClr val="7861AD"/>
+                  <a:srgbClr val="b9b0d5"/>
                 </a:solidFill>
                 <a:latin typeface="Arial"/>
                 <a:ea typeface="Arial"/>
@@ -12310,7 +12310,7 @@
             <a:lvl1pPr algn="l">
               <a:defRPr sz="1858" b="1">
                 <a:solidFill>
-                  <a:srgbClr val="7861AD"/>
+                  <a:srgbClr val="b9b0d5"/>
                 </a:solidFill>
                 <a:latin typeface="Arial"/>
                 <a:ea typeface="Arial"/>
@@ -12320,7 +12320,7 @@
             <a:lvl2pPr algn="l">
               <a:defRPr sz="1858" b="1">
                 <a:solidFill>
-                  <a:srgbClr val="7861AD"/>
+                  <a:srgbClr val="b9b0d5"/>
                 </a:solidFill>
                 <a:latin typeface="Arial"/>
                 <a:ea typeface="Arial"/>
@@ -12330,7 +12330,7 @@
             <a:lvl3pPr algn="l">
               <a:defRPr sz="1858" b="1">
                 <a:solidFill>
-                  <a:srgbClr val="7861AD"/>
+                  <a:srgbClr val="b9b0d5"/>
                 </a:solidFill>
                 <a:latin typeface="Arial"/>
                 <a:ea typeface="Arial"/>
@@ -12340,7 +12340,7 @@
             <a:lvl4pPr algn="l">
               <a:defRPr sz="1858" b="1">
                 <a:solidFill>
-                  <a:srgbClr val="7861AD"/>
+                  <a:srgbClr val="b9b0d5"/>
                 </a:solidFill>
                 <a:latin typeface="Arial"/>
                 <a:ea typeface="Arial"/>
@@ -12350,7 +12350,7 @@
             <a:lvl5pPr algn="l">
               <a:defRPr sz="1858" b="1">
                 <a:solidFill>
-                  <a:srgbClr val="7861AD"/>
+                  <a:srgbClr val="b9b0d5"/>
                 </a:solidFill>
                 <a:latin typeface="Arial"/>
                 <a:ea typeface="Arial"/>
@@ -12360,7 +12360,7 @@
             <a:lvl6pPr algn="l">
               <a:defRPr sz="1858" b="1">
                 <a:solidFill>
-                  <a:srgbClr val="7861AD"/>
+                  <a:srgbClr val="b9b0d5"/>
                 </a:solidFill>
                 <a:latin typeface="Arial"/>
                 <a:ea typeface="Arial"/>
@@ -12370,7 +12370,7 @@
             <a:lvl7pPr algn="l">
               <a:defRPr sz="1858" b="1">
                 <a:solidFill>
-                  <a:srgbClr val="7861AD"/>
+                  <a:srgbClr val="b9b0d5"/>
                 </a:solidFill>
                 <a:latin typeface="Arial"/>
                 <a:ea typeface="Arial"/>
@@ -12380,7 +12380,7 @@
             <a:lvl8pPr algn="l">
               <a:defRPr sz="1858" b="1">
                 <a:solidFill>
-                  <a:srgbClr val="7861AD"/>
+                  <a:srgbClr val="b9b0d5"/>
                 </a:solidFill>
                 <a:latin typeface="Arial"/>
                 <a:ea typeface="Arial"/>
@@ -12390,7 +12390,7 @@
             <a:lvl9pPr algn="l">
               <a:defRPr sz="1858" b="1">
                 <a:solidFill>
-                  <a:srgbClr val="7861AD"/>
+                  <a:srgbClr val="b9b0d5"/>
                 </a:solidFill>
                 <a:latin typeface="Arial"/>
                 <a:ea typeface="Arial"/>
@@ -12402,7 +12402,7 @@
             <a:pPr algn="l">
               <a:defRPr sz="1858" b="1">
                 <a:solidFill>
-                  <a:srgbClr val="7861AD"/>
+                  <a:srgbClr val="b9b0d5"/>
                 </a:solidFill>
                 <a:latin typeface="Arial"/>
                 <a:ea typeface="Arial"/>
@@ -12412,7 +12412,7 @@
             <a:r>
               <a:rPr sz="1858" b="1">
                 <a:solidFill>
-                  <a:srgbClr val="7861AD"/>
+                  <a:srgbClr val="b9b0d5"/>
                 </a:solidFill>
                 <a:latin typeface="Arial"/>
                 <a:ea typeface="Arial"/>
@@ -12459,7 +12459,7 @@
             <a:defPPr algn="l">
               <a:defRPr sz="1858" b="1">
                 <a:solidFill>
-                  <a:srgbClr val="7861AD"/>
+                  <a:srgbClr val="b9b0d5"/>
                 </a:solidFill>
                 <a:latin typeface="Arial"/>
                 <a:ea typeface="Arial"/>
@@ -12469,7 +12469,7 @@
             <a:lvl1pPr algn="l">
               <a:defRPr sz="1858" b="1">
                 <a:solidFill>
-                  <a:srgbClr val="7861AD"/>
+                  <a:srgbClr val="b9b0d5"/>
                 </a:solidFill>
                 <a:latin typeface="Arial"/>
                 <a:ea typeface="Arial"/>
@@ -12479,7 +12479,7 @@
             <a:lvl2pPr algn="l">
               <a:defRPr sz="1858" b="1">
                 <a:solidFill>
-                  <a:srgbClr val="7861AD"/>
+                  <a:srgbClr val="b9b0d5"/>
                 </a:solidFill>
                 <a:latin typeface="Arial"/>
                 <a:ea typeface="Arial"/>
@@ -12489,7 +12489,7 @@
             <a:lvl3pPr algn="l">
               <a:defRPr sz="1858" b="1">
                 <a:solidFill>
-                  <a:srgbClr val="7861AD"/>
+                  <a:srgbClr val="b9b0d5"/>
                 </a:solidFill>
                 <a:latin typeface="Arial"/>
                 <a:ea typeface="Arial"/>
@@ -12499,7 +12499,7 @@
             <a:lvl4pPr algn="l">
               <a:defRPr sz="1858" b="1">
                 <a:solidFill>
-                  <a:srgbClr val="7861AD"/>
+                  <a:srgbClr val="b9b0d5"/>
                 </a:solidFill>
                 <a:latin typeface="Arial"/>
                 <a:ea typeface="Arial"/>
@@ -12509,7 +12509,7 @@
             <a:lvl5pPr algn="l">
               <a:defRPr sz="1858" b="1">
                 <a:solidFill>
-                  <a:srgbClr val="7861AD"/>
+                  <a:srgbClr val="b9b0d5"/>
                 </a:solidFill>
                 <a:latin typeface="Arial"/>
                 <a:ea typeface="Arial"/>
@@ -12519,7 +12519,7 @@
             <a:lvl6pPr algn="l">
               <a:defRPr sz="1858" b="1">
                 <a:solidFill>
-                  <a:srgbClr val="7861AD"/>
+                  <a:srgbClr val="b9b0d5"/>
                 </a:solidFill>
                 <a:latin typeface="Arial"/>
                 <a:ea typeface="Arial"/>
@@ -12529,7 +12529,7 @@
             <a:lvl7pPr algn="l">
               <a:defRPr sz="1858" b="1">
                 <a:solidFill>
-                  <a:srgbClr val="7861AD"/>
+                  <a:srgbClr val="b9b0d5"/>
                 </a:solidFill>
                 <a:latin typeface="Arial"/>
                 <a:ea typeface="Arial"/>
@@ -12539,7 +12539,7 @@
             <a:lvl8pPr algn="l">
               <a:defRPr sz="1858" b="1">
                 <a:solidFill>
-                  <a:srgbClr val="7861AD"/>
+                  <a:srgbClr val="b9b0d5"/>
                 </a:solidFill>
                 <a:latin typeface="Arial"/>
                 <a:ea typeface="Arial"/>
@@ -12549,7 +12549,7 @@
             <a:lvl9pPr algn="l">
               <a:defRPr sz="1858" b="1">
                 <a:solidFill>
-                  <a:srgbClr val="7861AD"/>
+                  <a:srgbClr val="b9b0d5"/>
                 </a:solidFill>
                 <a:latin typeface="Arial"/>
                 <a:ea typeface="Arial"/>
@@ -12561,7 +12561,7 @@
             <a:pPr algn="l">
               <a:defRPr sz="1858" b="1">
                 <a:solidFill>
-                  <a:srgbClr val="7861AD"/>
+                  <a:srgbClr val="b9b0d5"/>
                 </a:solidFill>
                 <a:latin typeface="Arial"/>
                 <a:ea typeface="Arial"/>
@@ -12571,7 +12571,7 @@
             <a:r>
               <a:rPr sz="1858" b="1">
                 <a:solidFill>
-                  <a:srgbClr val="7861AD"/>
+                  <a:srgbClr val="b9b0d5"/>
                 </a:solidFill>
                 <a:latin typeface="Arial"/>
                 <a:ea typeface="Arial"/>
@@ -12618,7 +12618,7 @@
             <a:defPPr algn="l">
               <a:defRPr sz="2213" b="1">
                 <a:solidFill>
-                  <a:srgbClr val="1C2A40"/>
+                  <a:srgbClr val="8e96a2"/>
                 </a:solidFill>
                 <a:latin typeface="Arial"/>
                 <a:ea typeface="Arial"/>
@@ -12628,7 +12628,7 @@
             <a:lvl1pPr algn="l">
               <a:defRPr sz="2213" b="1">
                 <a:solidFill>
-                  <a:srgbClr val="1C2A40"/>
+                  <a:srgbClr val="8e96a2"/>
                 </a:solidFill>
                 <a:latin typeface="Arial"/>
                 <a:ea typeface="Arial"/>
@@ -12638,7 +12638,7 @@
             <a:lvl2pPr algn="l">
               <a:defRPr sz="2213" b="1">
                 <a:solidFill>
-                  <a:srgbClr val="1C2A40"/>
+                  <a:srgbClr val="8e96a2"/>
                 </a:solidFill>
                 <a:latin typeface="Arial"/>
                 <a:ea typeface="Arial"/>
@@ -12648,7 +12648,7 @@
             <a:lvl3pPr algn="l">
               <a:defRPr sz="2213" b="1">
                 <a:solidFill>
-                  <a:srgbClr val="1C2A40"/>
+                  <a:srgbClr val="8e96a2"/>
                 </a:solidFill>
                 <a:latin typeface="Arial"/>
                 <a:ea typeface="Arial"/>
@@ -12658,7 +12658,7 @@
             <a:lvl4pPr algn="l">
               <a:defRPr sz="2213" b="1">
                 <a:solidFill>
-                  <a:srgbClr val="1C2A40"/>
+                  <a:srgbClr val="8e96a2"/>
                 </a:solidFill>
                 <a:latin typeface="Arial"/>
                 <a:ea typeface="Arial"/>
@@ -12668,7 +12668,7 @@
             <a:lvl5pPr algn="l">
               <a:defRPr sz="2213" b="1">
                 <a:solidFill>
-                  <a:srgbClr val="1C2A40"/>
+                  <a:srgbClr val="8e96a2"/>
                 </a:solidFill>
                 <a:latin typeface="Arial"/>
                 <a:ea typeface="Arial"/>
@@ -12678,7 +12678,7 @@
             <a:lvl6pPr algn="l">
               <a:defRPr sz="2213" b="1">
                 <a:solidFill>
-                  <a:srgbClr val="1C2A40"/>
+                  <a:srgbClr val="8e96a2"/>
                 </a:solidFill>
                 <a:latin typeface="Arial"/>
                 <a:ea typeface="Arial"/>
@@ -12688,7 +12688,7 @@
             <a:lvl7pPr algn="l">
               <a:defRPr sz="2213" b="1">
                 <a:solidFill>
-                  <a:srgbClr val="1C2A40"/>
+                  <a:srgbClr val="8e96a2"/>
                 </a:solidFill>
                 <a:latin typeface="Arial"/>
                 <a:ea typeface="Arial"/>
@@ -12698,7 +12698,7 @@
             <a:lvl8pPr algn="l">
               <a:defRPr sz="2213" b="1">
                 <a:solidFill>
-                  <a:srgbClr val="1C2A40"/>
+                  <a:srgbClr val="8e96a2"/>
                 </a:solidFill>
                 <a:latin typeface="Arial"/>
                 <a:ea typeface="Arial"/>
@@ -12708,7 +12708,7 @@
             <a:lvl9pPr algn="l">
               <a:defRPr sz="2213" b="1">
                 <a:solidFill>
-                  <a:srgbClr val="1C2A40"/>
+                  <a:srgbClr val="8e96a2"/>
                 </a:solidFill>
                 <a:latin typeface="Arial"/>
                 <a:ea typeface="Arial"/>
@@ -12720,7 +12720,7 @@
             <a:pPr algn="l">
               <a:defRPr sz="2213" b="1">
                 <a:solidFill>
-                  <a:srgbClr val="1C2A40"/>
+                  <a:srgbClr val="8e96a2"/>
                 </a:solidFill>
                 <a:latin typeface="Arial"/>
                 <a:ea typeface="Arial"/>
@@ -12730,7 +12730,7 @@
             <a:r>
               <a:rPr sz="2213" b="1">
                 <a:solidFill>
-                  <a:srgbClr val="1C2A40"/>
+                  <a:srgbClr val="8e96a2"/>
                 </a:solidFill>
                 <a:latin typeface="Arial"/>
                 <a:ea typeface="Arial"/>

</xml_diff>